<commit_message>
deck, thesis: remove slot-enforcement claims; the race is two keepers on one UTxO
The claim vault enforces one claim before expiry, not per-keeper validity windows, and
the 04:35 and 04:44 runs executed as redundant races. Cover reframed to buying reliability.
</commit_message>
<xml_diff>
--- a/deck/cost-of-trust.pptx
+++ b/deck/cost-of-trust.pptx
@@ -3202,11 +3202,11 @@
               </a:defRPr>
             </a:pPr>
             <a:r>
-              <a:t>Your AI agent prices</a:t>
+              <a:t>Agents can buy reliability,</a:t>
             </a:r>
             <a:br/>
             <a:r>
-              <a:t>who to trust before it spends.</a:t>
+              <a:t>not just access.</a:t>
             </a:r>
           </a:p>
         </p:txBody>
@@ -3257,7 +3257,7 @@
               </a:defRPr>
             </a:pPr>
             <a:r>
-              <a:t>The cheapest keeper is not the cheapest route.</a:t>
+              <a:t>We do not rank agents. We decide how to buy the job.</a:t>
             </a:r>
           </a:p>
         </p:txBody>
@@ -3491,7 +3491,7 @@
               </a:defRPr>
             </a:pPr>
             <a:r>
-              <a:t>Cost of Trust  |  risk-priced routing for deadline work</a:t>
+              <a:t>Cost of Trust  |  how an agent buys a deadline job on Cardano</a:t>
             </a:r>
           </a:p>
         </p:txBody>
@@ -4250,7 +4250,7 @@
               </a:defRPr>
             </a:pPr>
             <a:r>
-              <a:t>Cost of Trust  |  your AI agent prices who to trust before it spends.</a:t>
+              <a:t>Cost of Trust  |  agents buy reliability, and Cardano enforces one winner.</a:t>
             </a:r>
           </a:p>
         </p:txBody>
@@ -9020,7 +9020,7 @@
               </a:defRPr>
             </a:pPr>
             <a:r>
-              <a:t>Schedule</a:t>
+              <a:t>Race</a:t>
             </a:r>
           </a:p>
         </p:txBody>
@@ -9071,7 +9071,7 @@
               </a:defRPr>
             </a:pPr>
             <a:r>
-              <a:t>Validity intervals give A the first slot and B the late slot.</a:t>
+              <a:t>Buyer pays two keepers. Both submit a claim on that UTxO.</a:t>
             </a:r>
           </a:p>
         </p:txBody>
@@ -9329,7 +9329,7 @@
               </a:defRPr>
             </a:pPr>
             <a:r>
-              <a:t>EUTXO contention pays the keeper whose slot lands.</a:t>
+              <a:t>The ledger accepts the first claim and refuses the second: BadInputsUTxO.</a:t>
             </a:r>
           </a:p>
         </p:txBody>
@@ -14403,7 +14403,7 @@
               </a:defRPr>
             </a:pPr>
             <a:r>
-              <a:t>staggered A &gt; B</a:t>
+              <a:t>redundant A + B</a:t>
             </a:r>
           </a:p>
         </p:txBody>
@@ -14460,7 +14460,7 @@
               </a:defRPr>
             </a:pPr>
             <a:r>
-              <a:t>seller A claims first slot</a:t>
+              <a:t>A claims, B refused by the ledger</a:t>
             </a:r>
           </a:p>
         </p:txBody>

</xml_diff>

<commit_message>
selection map numbers from the corrected router (bounded correlation, payout-matched coverage)
At loss 100: independent 10.82 / 14.89 / 18.96 / 26.98 ADA, shared 17.70 / 23.70 / 25.20 /
28.20 ADA for risk aversion 0 / 0.25 / 0.5 / 1; at 0.25 shared the route is now underwritten B.
</commit_message>
<xml_diff>
--- a/deck/cost-of-trust.pptx
+++ b/deck/cost-of-trust.pptx
@@ -6160,7 +6160,7 @@
             </a:r>
             <a:br/>
             <a:r>
-              <a:t>11.10 ADA</a:t>
+              <a:t>10.82 ADA</a:t>
             </a:r>
           </a:p>
         </p:txBody>
@@ -6221,7 +6221,7 @@
             </a:r>
             <a:br/>
             <a:r>
-              <a:t>18.24 ADA</a:t>
+              <a:t>17.70 ADA</a:t>
             </a:r>
           </a:p>
         </p:txBody>
@@ -6339,7 +6339,7 @@
             </a:r>
             <a:br/>
             <a:r>
-              <a:t>15.36 ADA</a:t>
+              <a:t>14.89 ADA</a:t>
             </a:r>
           </a:p>
         </p:txBody>
@@ -6396,11 +6396,11 @@
               </a:defRPr>
             </a:pPr>
             <a:r>
-              <a:t>Staggered B &gt; A</a:t>
+              <a:t>Underwritten B</a:t>
             </a:r>
             <a:br/>
             <a:r>
-              <a:t>25.75 ADA</a:t>
+              <a:t>23.70 ADA</a:t>
             </a:r>
           </a:p>
         </p:txBody>
@@ -6518,7 +6518,7 @@
             </a:r>
             <a:br/>
             <a:r>
-              <a:t>19.63 ADA</a:t>
+              <a:t>18.96 ADA</a:t>
             </a:r>
           </a:p>
         </p:txBody>
@@ -6579,7 +6579,7 @@
             </a:r>
             <a:br/>
             <a:r>
-              <a:t>29.60 ADA</a:t>
+              <a:t>25.20 ADA</a:t>
             </a:r>
           </a:p>
         </p:txBody>
@@ -6697,7 +6697,7 @@
             </a:r>
             <a:br/>
             <a:r>
-              <a:t>27.71 ADA</a:t>
+              <a:t>26.98 ADA</a:t>
             </a:r>
           </a:p>
         </p:txBody>
@@ -6758,7 +6758,7 @@
             </a:r>
             <a:br/>
             <a:r>
-              <a:t>37.00 ADA</a:t>
+              <a:t>28.20 ADA</a:t>
             </a:r>
           </a:p>
         </p:txBody>
@@ -8015,7 +8015,7 @@
               </a:defRPr>
             </a:pPr>
             <a:r>
-              <a:t>29.60 ADA</a:t>
+              <a:t>25.20 ADA</a:t>
             </a:r>
           </a:p>
         </p:txBody>

</xml_diff>